<commit_message>
docs(submission): 竞赛提交材料数字族对齐 2026-10-20 真值（261/95.02%/1693）
- 机检真值（2026-10-21 复算）：verify_auth_coverage 261/248/13/95.02%；openapi 全量 244/262（/api 243/261）；CI run 39467891052 → 1693/38/1/0（约 1741 collected）
- submission/00_提交清单.md：§二真值表 + 端点口径表 + 复算命令 + 权威口径行（覆盖率 61%→57.19%，TEST_TRUTH 口径）
- 02_配套文档：开发说明书（§八 + 新增 v2.5 修订行 + 目录/接口表）、技术方案说明书、系统架构设计文档（mermaid/表格/演进段）、快速启动指南、测试说明书
- docx 实体 3 份外科手术同步（开发/测试/系统架构 从 1389/1428 族 → 1693/95.02/261；历史 v2.2 修订行按约定保留）
- pptx 重生成：作品演示PPT-最终版（此前实体停在 10-06 族 1389/1428，10-17 轮只改生成器未重生成）+ 路演PPT；METRICS 单一真值源同步
- 证据页 + build_roadshow_pptx.py + generate_demo_ppt.py + py-server/README + TEST_TRUTH（覆盖率 SSOT 95.02、openapi 244/262）
- 两份 reconciliation 文档：头块真值行更新 + 追加 2026-10-21 同步节（含「包内 openapi 逐字节一致」声称的遗留警告）
</commit_message>
<xml_diff>
--- a/deliverables/芒得很职-国创赛路演PPT-5分钟黄金路径.pptx
+++ b/deliverables/芒得很职-国创赛路演PPT-5分钟黄金路径.pptx
@@ -862,7 +862,7 @@
           <a:lstStyle/>
           <a:p>
             <a:r>
-              <a:t>完整闭环已经跑通：选场景、两问画像、6 到 8 轮对抗、按 6 维 ECD 软素养评估、证据一致性校验、最后给出提升路径和报告。后端五张数据表、核心链路接口、包括越权拦截都已在代码级验证；全站 API 规模是 244 个操作、227 条路径，这是运行时 openapi 实测出来的，不是估的；认证覆盖率 94.67%。前端状态机、六维雷达和证据回放也都落地。这是演示里评委能直接看到的主路径。</a:t>
+              <a:t>完整闭环已经跑通：选场景、两问画像、6 到 8 轮对抗、按 6 维 ECD 软素养评估、证据一致性校验、最后给出提升路径和报告。后端五张数据表、核心链路接口、包括越权拦截都已在代码级验证；全站 API 规模是 261 个操作、243 条路径，这是运行时 openapi 实测出来的，不是估的；认证覆盖率 95.02%。前端状态机、六维雷达和证据回放也都落地。这是演示里评委能直接看到的主路径。</a:t>
             </a:r>
           </a:p>
         </p:txBody>
@@ -1072,7 +1072,7 @@
           <a:lstStyle/>
           <a:p>
             <a:r>
-              <a:t>我们不是只有 demo。技术底座已经拿到国家级大创立项，说明工程化能力是被认可的。更关键的是工程纪律：CI 默认档 1428 项，1389 通过、38 跳过、1 个预期失败、零失败，覆盖率 61%，超过 50 的门槛 11 个百分点；共识引擎实测均分 7.04、标准差 0.29，96 个样本、固定随机种子、6 个智能体，评委可以自己复现。和底座同源的知识图谱防伪证流水线，136 个节点、18 条边，验证报告自带 8 条机器检查守护，连"复现命令能不能在别人机器跑通"都有守护盯着。同一套"写下的结论必须能被机器复验"的纪律，同时保着两条产品线。这就是我们敢说"可信"的底气。</a:t>
+              <a:t>我们不是只有 demo。技术底座已经拿到国家级大创立项，说明工程化能力是被认可的。更关键的是工程纪律：CI 默认档 1732 run（1741 collected），1693 通过、38 跳过、1 个预期失败、零失败，覆盖率 57.19%，超过 50 的门槛 7.189999999999998 个百分点；共识引擎实测均分 7.04、标准差 0.29，96 个样本、固定随机种子、6 个智能体，评委可以自己复现。和底座同源的知识图谱防伪证流水线，136 个节点、18 条边，验证报告自带 8 条机器检查守护，连"复现命令能不能在别人机器跑通"都有守护盯着。同一套"写下的结论必须能被机器复验"的纪律，同时保着两条产品线。这就是我们敢说"可信"的底气。</a:t>
             </a:r>
           </a:p>
         </p:txBody>
@@ -5671,7 +5671,7 @@
               </a:defRPr>
             </a:pPr>
             <a:r>
-              <a:t>    - 全站 API 规模：244 operations / 227 paths（app.openapi() 运行时实测）</a:t>
+              <a:t>    - 全站 API 规模：261 operations / 243 paths（app.openapi() 运行时实测）</a:t>
             </a:r>
           </a:p>
           <a:p>
@@ -5690,7 +5690,7 @@
               </a:defRPr>
             </a:pPr>
             <a:r>
-              <a:t>    - 认证覆盖率 94.67%（231/244）</a:t>
+              <a:t>    - 认证覆盖率 95.02%（248/261）</a:t>
             </a:r>
           </a:p>
           <a:p>
@@ -6521,7 +6521,7 @@
               </a:defRPr>
             </a:pPr>
             <a:r>
-              <a:t>• 质量门禁可复现：CI 默认档 1428 项 → 1389 passed / 38 skipped / 1 xfailed / 0 failed</a:t>
+              <a:t>• 质量门禁可复现：CI 默认档 1732 run（1741 collected）→ 1693 passed / 38 skipped / 1 xfailed / 0 failed</a:t>
             </a:r>
           </a:p>
           <a:p>
@@ -6540,7 +6540,7 @@
               </a:defRPr>
             </a:pPr>
             <a:r>
-              <a:t>    - CI p0 档 67 条；覆盖率 61%（门禁 --cov-fail-under=50，余量 11pp）</a:t>
+              <a:t>    - CI p0 档 67 条；覆盖率 57.19%（门禁 --cov-fail-under=50，余量 7.189999999999998pp）</a:t>
             </a:r>
           </a:p>
           <a:p>

</xml_diff>